<commit_message>
Update lesson 08 slides
</commit_message>
<xml_diff>
--- a/slides/lesson-08-spec-driven-development-biomedical-tools.pptx
+++ b/slides/lesson-08-spec-driven-development-biomedical-tools.pptx
@@ -46070,7 +46070,7 @@
           <a:bodyPr/>
           <a:lstStyle/>
           <a:p>
-            <a:endParaRPr lang="zh-TW" altLang="en-US"/>
+            <a:endParaRPr lang="zh-TW" altLang="en-US" sz="2400"/>
           </a:p>
         </p:txBody>
       </p:sp>
@@ -46121,7 +46121,7 @@
               </a:defRPr>
             </a:pPr>
             <a:r>
-              <a:rPr sz="1125" b="1">
+              <a:rPr sz="1400" b="1">
                 <a:solidFill>
                   <a:srgbClr val="17202A"/>
                 </a:solidFill>
@@ -46172,7 +46172,7 @@
           <a:bodyPr/>
           <a:lstStyle/>
           <a:p>
-            <a:endParaRPr lang="zh-TW" altLang="en-US"/>
+            <a:endParaRPr lang="zh-TW" altLang="en-US" sz="2400"/>
           </a:p>
         </p:txBody>
       </p:sp>
@@ -46223,7 +46223,7 @@
               </a:defRPr>
             </a:pPr>
             <a:r>
-              <a:rPr sz="1125" b="0">
+              <a:rPr sz="1400" b="0">
                 <a:solidFill>
                   <a:srgbClr val="5C6670"/>
                 </a:solidFill>
@@ -46274,7 +46274,7 @@
           <a:bodyPr/>
           <a:lstStyle/>
           <a:p>
-            <a:endParaRPr lang="zh-TW" altLang="en-US"/>
+            <a:endParaRPr lang="zh-TW" altLang="en-US" sz="2400"/>
           </a:p>
         </p:txBody>
       </p:sp>
@@ -46325,7 +46325,7 @@
               </a:defRPr>
             </a:pPr>
             <a:r>
-              <a:rPr sz="1125" b="0">
+              <a:rPr sz="1400" b="0">
                 <a:solidFill>
                   <a:srgbClr val="5C6670"/>
                 </a:solidFill>
@@ -46376,7 +46376,7 @@
           <a:bodyPr/>
           <a:lstStyle/>
           <a:p>
-            <a:endParaRPr lang="zh-TW" altLang="en-US"/>
+            <a:endParaRPr lang="zh-TW" altLang="en-US" sz="2400"/>
           </a:p>
         </p:txBody>
       </p:sp>
@@ -46427,7 +46427,7 @@
               </a:defRPr>
             </a:pPr>
             <a:r>
-              <a:rPr sz="1125" b="1">
+              <a:rPr sz="1400" b="1">
                 <a:solidFill>
                   <a:srgbClr val="17202A"/>
                 </a:solidFill>
@@ -46478,7 +46478,7 @@
           <a:bodyPr/>
           <a:lstStyle/>
           <a:p>
-            <a:endParaRPr lang="zh-TW" altLang="en-US"/>
+            <a:endParaRPr lang="zh-TW" altLang="en-US" sz="2400"/>
           </a:p>
         </p:txBody>
       </p:sp>
@@ -46529,7 +46529,7 @@
               </a:defRPr>
             </a:pPr>
             <a:r>
-              <a:rPr sz="1125" b="0">
+              <a:rPr sz="1400" b="0">
                 <a:solidFill>
                   <a:srgbClr val="5C6670"/>
                 </a:solidFill>
@@ -46580,7 +46580,7 @@
           <a:bodyPr/>
           <a:lstStyle/>
           <a:p>
-            <a:endParaRPr lang="zh-TW" altLang="en-US"/>
+            <a:endParaRPr lang="zh-TW" altLang="en-US" sz="2400"/>
           </a:p>
         </p:txBody>
       </p:sp>
@@ -46631,7 +46631,7 @@
               </a:defRPr>
             </a:pPr>
             <a:r>
-              <a:rPr sz="1125" b="0">
+              <a:rPr sz="1400" b="0">
                 <a:solidFill>
                   <a:srgbClr val="5C6670"/>
                 </a:solidFill>
@@ -46682,7 +46682,7 @@
           <a:bodyPr/>
           <a:lstStyle/>
           <a:p>
-            <a:endParaRPr lang="zh-TW" altLang="en-US"/>
+            <a:endParaRPr lang="zh-TW" altLang="en-US" sz="2400"/>
           </a:p>
         </p:txBody>
       </p:sp>
@@ -46733,7 +46733,7 @@
               </a:defRPr>
             </a:pPr>
             <a:r>
-              <a:rPr sz="1125" b="1">
+              <a:rPr sz="1400" b="1">
                 <a:solidFill>
                   <a:srgbClr val="17202A"/>
                 </a:solidFill>
@@ -46784,7 +46784,7 @@
           <a:bodyPr/>
           <a:lstStyle/>
           <a:p>
-            <a:endParaRPr lang="zh-TW" altLang="en-US"/>
+            <a:endParaRPr lang="zh-TW" altLang="en-US" sz="2400"/>
           </a:p>
         </p:txBody>
       </p:sp>
@@ -46835,7 +46835,7 @@
               </a:defRPr>
             </a:pPr>
             <a:r>
-              <a:rPr sz="1125" b="0">
+              <a:rPr sz="1400" b="0">
                 <a:solidFill>
                   <a:srgbClr val="5C6670"/>
                 </a:solidFill>
@@ -46886,7 +46886,7 @@
           <a:bodyPr/>
           <a:lstStyle/>
           <a:p>
-            <a:endParaRPr lang="zh-TW" altLang="en-US"/>
+            <a:endParaRPr lang="zh-TW" altLang="en-US" sz="2400"/>
           </a:p>
         </p:txBody>
       </p:sp>
@@ -46937,7 +46937,7 @@
               </a:defRPr>
             </a:pPr>
             <a:r>
-              <a:rPr sz="1125" b="0">
+              <a:rPr sz="1400" b="0">
                 <a:solidFill>
                   <a:srgbClr val="5C6670"/>
                 </a:solidFill>
@@ -46988,7 +46988,7 @@
           <a:bodyPr/>
           <a:lstStyle/>
           <a:p>
-            <a:endParaRPr lang="zh-TW" altLang="en-US"/>
+            <a:endParaRPr lang="zh-TW" altLang="en-US" sz="2400"/>
           </a:p>
         </p:txBody>
       </p:sp>
@@ -47039,7 +47039,7 @@
               </a:defRPr>
             </a:pPr>
             <a:r>
-              <a:rPr sz="1125" b="1">
+              <a:rPr sz="1400" b="1">
                 <a:solidFill>
                   <a:srgbClr val="17202A"/>
                 </a:solidFill>
@@ -47090,7 +47090,7 @@
           <a:bodyPr/>
           <a:lstStyle/>
           <a:p>
-            <a:endParaRPr lang="zh-TW" altLang="en-US"/>
+            <a:endParaRPr lang="zh-TW" altLang="en-US" sz="2400"/>
           </a:p>
         </p:txBody>
       </p:sp>
@@ -47141,7 +47141,7 @@
               </a:defRPr>
             </a:pPr>
             <a:r>
-              <a:rPr sz="1125" b="0">
+              <a:rPr sz="1400" b="0">
                 <a:solidFill>
                   <a:srgbClr val="5C6670"/>
                 </a:solidFill>
@@ -47192,7 +47192,7 @@
           <a:bodyPr/>
           <a:lstStyle/>
           <a:p>
-            <a:endParaRPr lang="zh-TW" altLang="en-US"/>
+            <a:endParaRPr lang="zh-TW" altLang="en-US" sz="2400"/>
           </a:p>
         </p:txBody>
       </p:sp>
@@ -47243,7 +47243,7 @@
               </a:defRPr>
             </a:pPr>
             <a:r>
-              <a:rPr sz="1125" b="0">
+              <a:rPr sz="1400" b="0">
                 <a:solidFill>
                   <a:srgbClr val="5C6670"/>
                 </a:solidFill>

</xml_diff>